<commit_message>
deck: rewrite KPI math for \$600/yr + \$50/lead pricing
Replace incorrect Growth/Enterprise tier model with actual pricing:
\$600/year subscription billed upfront + \$50 per quote-form-submit lead.

Updated slides:
- Slide 2 (North Star): formula N × \$50 + leads × \$50
- Slide 3 (Regnestykket): three new scenarios at \$4,400/md (≈30k DKK)
- Slide 4 (Two funnels): supplier step now "sign \$600/yr contract"
- Slide 5 (Buyer KPIs): quote-form-submit is now the headline revenue KPI
- Slide 6 (Supplier KPIs): "annual revenue booked" + renewal-rate replace MRR/churn
- Slide 7 (Baseline): revenue banked YTD = \$600 (1 partner), gap = \$4,350/md
- Slide 8 (Funnel pyramid): headline = lift quote-conversion 0.25% → 0.5%
- Slide 10 (Gaps): partner_subscriptions simplified, partner_leads added
- Slide 11 (90-day plan): lead-attribution moved to weeks 1-3 (revenue-critical)
- Slide 12 (Sources): updated data-source references

Co-Authored-By: Claude Opus 4.7 (1M context) <noreply@anthropic.com>
</commit_message>
<xml_diff>
--- a/SupplyCheck_Weekly_KPI_Deck.pptx
+++ b/SupplyCheck_Weekly_KPI_Deck.pptx
@@ -3982,7 +3982,7 @@
                 </a:solidFill>
                 <a:latin typeface="Arial"/>
               </a:rPr>
-              <a:t>Driver KPI #11 (MRR) og #12 (Churn)</a:t>
+              <a:t>Driver KPI #10/#11 (Revenue booked + Renewal)</a:t>
             </a:r>
           </a:p>
         </p:txBody>
@@ -4017,7 +4017,7 @@
                 </a:solidFill>
                 <a:latin typeface="Arial"/>
               </a:rPr>
-              <a:t>Kolonner: supplier_id, tier (growth/enterprise), mrr_dkk, started_at, cancelled_at. Manuel for nu, automatiser når Stripe er på.</a:t>
+              <a:t>Simpel: supplier_id, paid_amount_usd (600), paid_at, expires_at (+12md), renewal_status. Ingen tiers. Manuel fakturering for nu, Stripe senere.</a:t>
             </a:r>
           </a:p>
         </p:txBody>
@@ -4216,7 +4216,7 @@
                 </a:solidFill>
                 <a:latin typeface="Georgia"/>
               </a:rPr>
-              <a:t>Lead-attribution pr. supplier</a:t>
+              <a:t>Lead-attribution (revenue-kritisk)</a:t>
             </a:r>
           </a:p>
         </p:txBody>
@@ -4251,7 +4251,7 @@
                 </a:solidFill>
                 <a:latin typeface="Arial"/>
               </a:rPr>
-              <a:t>Driver KPI #8 (Leads leveret)</a:t>
+              <a:t>Driver KPI #5 ($50/lead) + KPI #8</a:t>
             </a:r>
           </a:p>
         </p:txBody>
@@ -4286,7 +4286,7 @@
                 </a:solidFill>
                 <a:latin typeface="Arial"/>
               </a:rPr>
-              <a:t>Link outbound_click + quote_request_submit til supplier_id. Memory: selectItems/searches/supplier_id mangler GTM-tagging — samme rod.</a:t>
+              <a:t>Tilføj supplier_id til quote_request_submit-event + ny partner_leads tabel. Hver utracket submit = $50 tabt. Samtidig fix: selectItems/searches/supplier_id GTM-tagging.</a:t>
             </a:r>
           </a:p>
         </p:txBody>
@@ -4987,7 +4987,7 @@
                 </a:solidFill>
                 <a:latin typeface="Georgia"/>
               </a:rPr>
-              <a:t>INSTRUMENTATION</a:t>
+              <a:t>LEAD-ATTRIBUTION</a:t>
             </a:r>
           </a:p>
         </p:txBody>
@@ -5022,7 +5022,7 @@
                 </a:solidFill>
                 <a:latin typeface="Arial"/>
               </a:rPr>
-              <a:t>Byg MRR-tabel · Fix lead-attribution · MAU-query i admin</a:t>
+              <a:t>Tilføj supplier_id til quote_submit · partner_leads tabel · partner_subscriptions tabel · MAU-query</a:t>
             </a:r>
           </a:p>
         </p:txBody>
@@ -5178,7 +5178,7 @@
                 </a:solidFill>
                 <a:latin typeface="Georgia"/>
               </a:rPr>
-              <a:t>BUYER TOP-OF-FUNNEL</a:t>
+              <a:t>BUYER CONVERSION</a:t>
             </a:r>
           </a:p>
         </p:txBody>
@@ -5213,7 +5213,7 @@
                 </a:solidFill>
                 <a:latin typeface="Arial"/>
               </a:rPr>
-              <a:t>SEO-content · Compare-prices-side · landing-page tests for at hæve unikke besøgende</a:t>
+              <a:t>Quote-form-UX · CTA-tests · STL-flow · lift quote-submit fra 0,25% → 0,5% = 2× lead-revenue</a:t>
             </a:r>
           </a:p>
         </p:txBody>
@@ -5369,7 +5369,7 @@
                 </a:solidFill>
                 <a:latin typeface="Georgia"/>
               </a:rPr>
-              <a:t>BUYER CONVERSION</a:t>
+              <a:t>BUYER TOP-OF-FUNNEL</a:t>
             </a:r>
           </a:p>
         </p:txBody>
@@ -5404,7 +5404,7 @@
                 </a:solidFill>
                 <a:latin typeface="Arial"/>
               </a:rPr>
-              <a:t>Optimér STL-upload-flow · supplier-card design · CTA-test for at hæve 3% → 5%</a:t>
+              <a:t>SEO-content · Compare-prices-side · landing pages · hæv MAU fra X → 10k for mere lead-volumen</a:t>
             </a:r>
           </a:p>
         </p:txBody>
@@ -5595,7 +5595,7 @@
                 </a:solidFill>
                 <a:latin typeface="Arial"/>
               </a:rPr>
-              <a:t>Outreach til top-25 suppliers · pricing-samtaler · få 3 nye Growth-partnere underskrevet</a:t>
+              <a:t>Outreach til top-25 suppliers · vis dem leads-rapport · få 3 nye $600/år-kontrakter underskrevet</a:t>
             </a:r>
           </a:p>
         </p:txBody>
@@ -5673,7 +5673,7 @@
                 </a:solidFill>
                 <a:latin typeface="Arial"/>
               </a:rPr>
-              <a:t>EFTER 90 DAGE:  baseline = 4.000 besøgende/uge  ·  4% conversion  ·  4 nye Growth-partnere  ·  9.000 DKK MRR</a:t>
+              <a:t>EFTER 90 DAGE:  4 nye partnere × $600 = $2.400 booked  ·  0,5% quote-conversion  ·  ~$1.250/md lead-revenue</a:t>
             </a:r>
           </a:p>
         </p:txBody>
@@ -6936,7 +6936,7 @@
                 </a:solidFill>
                 <a:latin typeface="Georgia"/>
               </a:rPr>
-              <a:t>KPI #11-12 (Revenue) — BYG</a:t>
+              <a:t>KPI #5/#10/#11 (Revenue) — BYG</a:t>
             </a:r>
           </a:p>
         </p:txBody>
@@ -7014,7 +7014,7 @@
                 </a:solidFill>
                 <a:latin typeface="Arial"/>
               </a:rPr>
-              <a:t>partner_subscriptions tabel: SKAL OPRETTES</a:t>
+              <a:t>partner_subscriptions: supplier_id, paid_at, expires_at, $600</a:t>
             </a:r>
           </a:p>
         </p:txBody>
@@ -7092,7 +7092,7 @@
                 </a:solidFill>
                 <a:latin typeface="Arial"/>
               </a:rPr>
-              <a:t>Stripe-webhook: ikke koblet på endnu</a:t>
+              <a:t>partner_leads: quote_event_id → supplier_id → $50</a:t>
             </a:r>
           </a:p>
         </p:txBody>
@@ -7170,7 +7170,7 @@
                 </a:solidFill>
                 <a:latin typeface="Arial"/>
               </a:rPr>
-              <a:t>MRR-query: SUM(mrr_dkk) WHERE cancelled_at IS NULL</a:t>
+              <a:t>Manuel fakturering (Stripe senere)</a:t>
             </a:r>
           </a:p>
         </p:txBody>
@@ -7755,20 +7755,213 @@
           <a:p>
             <a:pPr algn="ctr">
               <a:lnSpc>
-                <a:spcPct val="120000"/>
+                <a:spcPct val="115000"/>
               </a:lnSpc>
             </a:pPr>
             <a:r>
-              <a:rPr sz="2200" b="1">
+              <a:rPr sz="1800" b="1">
                 <a:solidFill>
                   <a:srgbClr val="FFFFFF"/>
                 </a:solidFill>
                 <a:latin typeface="Georgia"/>
               </a:rPr>
-              <a:t>Konvertering
+              <a:t>Revenue-formel
 </a:t>
             </a:r>
           </a:p>
+          <a:p>
+            <a:pPr algn="ctr">
+              <a:lnSpc>
+                <a:spcPct val="115000"/>
+              </a:lnSpc>
+            </a:pPr>
+            <a:r>
+              <a:rPr sz="600" b="0">
+                <a:solidFill>
+                  <a:srgbClr val="FFFFFF"/>
+                </a:solidFill>
+                <a:latin typeface="Arial"/>
+              </a:rPr>
+              <a:t>
+</a:t>
+            </a:r>
+          </a:p>
+          <a:p>
+            <a:pPr algn="ctr">
+              <a:lnSpc>
+                <a:spcPct val="115000"/>
+              </a:lnSpc>
+            </a:pPr>
+            <a:r>
+              <a:rPr sz="1600" b="1">
+                <a:solidFill>
+                  <a:srgbClr val="6B8F3C"/>
+                </a:solidFill>
+                <a:latin typeface="Arial"/>
+              </a:rPr>
+              <a:t>N × $50 + Leads × $50
+</a:t>
+            </a:r>
+          </a:p>
+          <a:p>
+            <a:pPr algn="ctr">
+              <a:lnSpc>
+                <a:spcPct val="115000"/>
+              </a:lnSpc>
+            </a:pPr>
+            <a:r>
+              <a:rPr sz="600" b="0">
+                <a:solidFill>
+                  <a:srgbClr val="FFFFFF"/>
+                </a:solidFill>
+                <a:latin typeface="Arial"/>
+              </a:rPr>
+              <a:t>
+</a:t>
+            </a:r>
+          </a:p>
+          <a:p>
+            <a:pPr algn="ctr">
+              <a:lnSpc>
+                <a:spcPct val="115000"/>
+              </a:lnSpc>
+            </a:pPr>
+            <a:r>
+              <a:rPr sz="1100" b="0">
+                <a:solidFill>
+                  <a:srgbClr val="F2F2F2"/>
+                </a:solidFill>
+                <a:latin typeface="Arial"/>
+              </a:rPr>
+              <a:t>$600/år subscription
+</a:t>
+            </a:r>
+          </a:p>
+          <a:p>
+            <a:pPr algn="ctr">
+              <a:lnSpc>
+                <a:spcPct val="115000"/>
+              </a:lnSpc>
+            </a:pPr>
+            <a:r>
+              <a:rPr sz="1100" b="0">
+                <a:solidFill>
+                  <a:srgbClr val="F2F2F2"/>
+                </a:solidFill>
+                <a:latin typeface="Arial"/>
+              </a:rPr>
+              <a:t>+ $50 pr. quote-form-submit</a:t>
+            </a:r>
+          </a:p>
+        </p:txBody>
+      </p:sp>
+      <p:sp>
+        <p:nvSpPr>
+          <p:cNvPr id="14" name="Right Arrow 13"/>
+          <p:cNvSpPr/>
+          <p:nvPr/>
+        </p:nvSpPr>
+        <p:spPr>
+          <a:xfrm>
+            <a:off x="7741767" y="3429000"/>
+            <a:ext cx="365760" cy="457200"/>
+          </a:xfrm>
+          <a:prstGeom prst="rightArrow">
+            <a:avLst/>
+          </a:prstGeom>
+          <a:solidFill>
+            <a:srgbClr val="6B8F3C"/>
+          </a:solidFill>
+          <a:ln>
+            <a:noFill/>
+          </a:ln>
+        </p:spPr>
+        <p:style>
+          <a:lnRef idx="1">
+            <a:schemeClr val="accent1"/>
+          </a:lnRef>
+          <a:fillRef idx="3">
+            <a:schemeClr val="accent1"/>
+          </a:fillRef>
+          <a:effectRef idx="2">
+            <a:schemeClr val="accent1"/>
+          </a:effectRef>
+          <a:fontRef idx="minor">
+            <a:schemeClr val="lt1"/>
+          </a:fontRef>
+        </p:style>
+        <p:txBody>
+          <a:bodyPr rtlCol="0" anchor="ctr"/>
+          <a:lstStyle/>
+          <a:p>
+            <a:pPr algn="ctr"/>
+          </a:p>
+        </p:txBody>
+      </p:sp>
+      <p:sp>
+        <p:nvSpPr>
+          <p:cNvPr id="15" name="Rounded Rectangle 14"/>
+          <p:cNvSpPr/>
+          <p:nvPr/>
+        </p:nvSpPr>
+        <p:spPr>
+          <a:xfrm>
+            <a:off x="8107527" y="2560320"/>
+            <a:ext cx="3291840" cy="2194560"/>
+          </a:xfrm>
+          <a:prstGeom prst="roundRect">
+            <a:avLst/>
+          </a:prstGeom>
+          <a:solidFill>
+            <a:srgbClr val="FFFFFF"/>
+          </a:solidFill>
+          <a:ln>
+            <a:noFill/>
+          </a:ln>
+        </p:spPr>
+        <p:style>
+          <a:lnRef idx="1">
+            <a:schemeClr val="accent1"/>
+          </a:lnRef>
+          <a:fillRef idx="3">
+            <a:schemeClr val="accent1"/>
+          </a:fillRef>
+          <a:effectRef idx="2">
+            <a:schemeClr val="accent1"/>
+          </a:effectRef>
+          <a:fontRef idx="minor">
+            <a:schemeClr val="lt1"/>
+          </a:fontRef>
+        </p:style>
+        <p:txBody>
+          <a:bodyPr rtlCol="0" anchor="ctr"/>
+          <a:lstStyle/>
+          <a:p>
+            <a:pPr algn="ctr"/>
+          </a:p>
+        </p:txBody>
+      </p:sp>
+      <p:sp>
+        <p:nvSpPr>
+          <p:cNvPr id="16" name="TextBox 15"/>
+          <p:cNvSpPr txBox="1"/>
+          <p:nvPr/>
+        </p:nvSpPr>
+        <p:spPr>
+          <a:xfrm>
+            <a:off x="8107527" y="2560320"/>
+            <a:ext cx="3291840" cy="2194560"/>
+          </a:xfrm>
+          <a:prstGeom prst="rect">
+            <a:avLst/>
+          </a:prstGeom>
+          <a:noFill/>
+        </p:spPr>
+        <p:txBody>
+          <a:bodyPr wrap="square" lIns="45720" rIns="45720" tIns="18288" bIns="18288" anchor="ctr">
+            <a:spAutoFit/>
+          </a:bodyPr>
+          <a:lstStyle/>
           <a:p>
             <a:pPr algn="ctr">
               <a:lnSpc>
@@ -7776,13 +7969,13 @@
               </a:lnSpc>
             </a:pPr>
             <a:r>
-              <a:rPr sz="800" b="0">
-                <a:solidFill>
-                  <a:srgbClr val="FFFFFF"/>
-                </a:solidFill>
-                <a:latin typeface="Arial"/>
-              </a:rPr>
-              <a:t>
+              <a:rPr sz="5600" b="1">
+                <a:solidFill>
+                  <a:srgbClr val="4F6C2A"/>
+                </a:solidFill>
+                <a:latin typeface="Georgia"/>
+              </a:rPr>
+              <a:t>30.000
 </a:t>
             </a:r>
           </a:p>
@@ -7793,13 +7986,13 @@
               </a:lnSpc>
             </a:pPr>
             <a:r>
-              <a:rPr sz="1300" b="0">
-                <a:solidFill>
-                  <a:srgbClr val="F2F2F2"/>
+              <a:rPr sz="1400" b="0">
+                <a:solidFill>
+                  <a:srgbClr val="555555"/>
                 </a:solidFill>
                 <a:latin typeface="Arial"/>
               </a:rPr>
-              <a:t>Buyer-funnel + Supplier-funnel
+              <a:t>DKK/måned i løn
 </a:t>
             </a:r>
           </a:p>
@@ -7810,172 +8003,13 @@
               </a:lnSpc>
             </a:pPr>
             <a:r>
-              <a:rPr sz="1100" b="1">
-                <a:solidFill>
-                  <a:srgbClr val="6B8F3C"/>
+              <a:rPr sz="1100" b="0">
+                <a:solidFill>
+                  <a:srgbClr val="555555"/>
                 </a:solidFill>
                 <a:latin typeface="Arial"/>
               </a:rPr>
-              <a:t>Måles ugentligt</a:t>
-            </a:r>
-          </a:p>
-        </p:txBody>
-      </p:sp>
-      <p:sp>
-        <p:nvSpPr>
-          <p:cNvPr id="14" name="Right Arrow 13"/>
-          <p:cNvSpPr/>
-          <p:nvPr/>
-        </p:nvSpPr>
-        <p:spPr>
-          <a:xfrm>
-            <a:off x="7741767" y="3429000"/>
-            <a:ext cx="365760" cy="457200"/>
-          </a:xfrm>
-          <a:prstGeom prst="rightArrow">
-            <a:avLst/>
-          </a:prstGeom>
-          <a:solidFill>
-            <a:srgbClr val="6B8F3C"/>
-          </a:solidFill>
-          <a:ln>
-            <a:noFill/>
-          </a:ln>
-        </p:spPr>
-        <p:style>
-          <a:lnRef idx="1">
-            <a:schemeClr val="accent1"/>
-          </a:lnRef>
-          <a:fillRef idx="3">
-            <a:schemeClr val="accent1"/>
-          </a:fillRef>
-          <a:effectRef idx="2">
-            <a:schemeClr val="accent1"/>
-          </a:effectRef>
-          <a:fontRef idx="minor">
-            <a:schemeClr val="lt1"/>
-          </a:fontRef>
-        </p:style>
-        <p:txBody>
-          <a:bodyPr rtlCol="0" anchor="ctr"/>
-          <a:lstStyle/>
-          <a:p>
-            <a:pPr algn="ctr"/>
-          </a:p>
-        </p:txBody>
-      </p:sp>
-      <p:sp>
-        <p:nvSpPr>
-          <p:cNvPr id="15" name="Rounded Rectangle 14"/>
-          <p:cNvSpPr/>
-          <p:nvPr/>
-        </p:nvSpPr>
-        <p:spPr>
-          <a:xfrm>
-            <a:off x="8107527" y="2560320"/>
-            <a:ext cx="3291840" cy="2194560"/>
-          </a:xfrm>
-          <a:prstGeom prst="roundRect">
-            <a:avLst/>
-          </a:prstGeom>
-          <a:solidFill>
-            <a:srgbClr val="FFFFFF"/>
-          </a:solidFill>
-          <a:ln>
-            <a:noFill/>
-          </a:ln>
-        </p:spPr>
-        <p:style>
-          <a:lnRef idx="1">
-            <a:schemeClr val="accent1"/>
-          </a:lnRef>
-          <a:fillRef idx="3">
-            <a:schemeClr val="accent1"/>
-          </a:fillRef>
-          <a:effectRef idx="2">
-            <a:schemeClr val="accent1"/>
-          </a:effectRef>
-          <a:fontRef idx="minor">
-            <a:schemeClr val="lt1"/>
-          </a:fontRef>
-        </p:style>
-        <p:txBody>
-          <a:bodyPr rtlCol="0" anchor="ctr"/>
-          <a:lstStyle/>
-          <a:p>
-            <a:pPr algn="ctr"/>
-          </a:p>
-        </p:txBody>
-      </p:sp>
-      <p:sp>
-        <p:nvSpPr>
-          <p:cNvPr id="16" name="TextBox 15"/>
-          <p:cNvSpPr txBox="1"/>
-          <p:nvPr/>
-        </p:nvSpPr>
-        <p:spPr>
-          <a:xfrm>
-            <a:off x="8107527" y="2560320"/>
-            <a:ext cx="3291840" cy="2194560"/>
-          </a:xfrm>
-          <a:prstGeom prst="rect">
-            <a:avLst/>
-          </a:prstGeom>
-          <a:noFill/>
-        </p:spPr>
-        <p:txBody>
-          <a:bodyPr wrap="square" lIns="45720" rIns="45720" tIns="18288" bIns="18288" anchor="ctr">
-            <a:spAutoFit/>
-          </a:bodyPr>
-          <a:lstStyle/>
-          <a:p>
-            <a:pPr algn="ctr">
-              <a:lnSpc>
-                <a:spcPct val="120000"/>
-              </a:lnSpc>
-            </a:pPr>
-            <a:r>
-              <a:rPr sz="5600" b="1">
-                <a:solidFill>
-                  <a:srgbClr val="4F6C2A"/>
-                </a:solidFill>
-                <a:latin typeface="Georgia"/>
-              </a:rPr>
-              <a:t>30.000
-</a:t>
-            </a:r>
-          </a:p>
-          <a:p>
-            <a:pPr algn="ctr">
-              <a:lnSpc>
-                <a:spcPct val="120000"/>
-              </a:lnSpc>
-            </a:pPr>
-            <a:r>
-              <a:rPr sz="1400" b="0">
-                <a:solidFill>
-                  <a:srgbClr val="555555"/>
-                </a:solidFill>
-                <a:latin typeface="Arial"/>
-              </a:rPr>
-              <a:t>DKK/måned i løn
-</a:t>
-            </a:r>
-          </a:p>
-          <a:p>
-            <a:pPr algn="ctr">
-              <a:lnSpc>
-                <a:spcPct val="120000"/>
-              </a:lnSpc>
-            </a:pPr>
-            <a:r>
-              <a:rPr sz="1100" b="0">
-                <a:solidFill>
-                  <a:srgbClr val="555555"/>
-                </a:solidFill>
-                <a:latin typeface="Arial"/>
-              </a:rPr>
-              <a:t>≈ €4.025 MRR fra partnere</a:t>
+              <a:t>≈ $4.400/md fra partnere</a:t>
             </a:r>
           </a:p>
         </p:txBody>
@@ -8004,13 +8038,13 @@
           <a:p>
             <a:pPr algn="ctr"/>
             <a:r>
-              <a:rPr sz="1400" b="0">
+              <a:rPr sz="1300" b="0">
                 <a:solidFill>
                   <a:srgbClr val="555555"/>
                 </a:solidFill>
                 <a:latin typeface="Arial"/>
               </a:rPr>
-              <a:t>Det er IKKE 10k → 27 partnere direkte. 10k buyer-trafik skaber value · value skaber partnere.</a:t>
+              <a:t>10k besøgende konverterer IKKE direkte til 40 partnere. Trafik driver leads ($50/stk) · outreach driver subscriptions ($600/år).</a:t>
             </a:r>
           </a:p>
         </p:txBody>
@@ -8264,8 +8298,8 @@
         </p:nvSpPr>
         <p:spPr>
           <a:xfrm>
-            <a:off x="457200" y="1554480"/>
-            <a:ext cx="11277295" cy="548640"/>
+            <a:off x="457200" y="1417320"/>
+            <a:ext cx="11277295" cy="457200"/>
           </a:xfrm>
           <a:prstGeom prst="rect">
             <a:avLst/>
@@ -8280,26 +8314,61 @@
           <a:p>
             <a:pPr algn="ctr"/>
             <a:r>
-              <a:rPr sz="2400" b="1">
+              <a:rPr sz="2200" b="1">
                 <a:solidFill>
                   <a:srgbClr val="333333"/>
                 </a:solidFill>
                 <a:latin typeface="Georgia"/>
               </a:rPr>
-              <a:t>30.000 DKK/md  ≈  €4.025 MRR  (kurs 7,45)</a:t>
-            </a:r>
-          </a:p>
-        </p:txBody>
-      </p:sp>
-      <p:sp>
-        <p:nvSpPr>
-          <p:cNvPr id="9" name="Rounded Rectangle 8"/>
+              <a:t>30.000 DKK/md  ≈  $4.400/md  (kurs 6,85 DKK/USD)</a:t>
+            </a:r>
+          </a:p>
+        </p:txBody>
+      </p:sp>
+      <p:sp>
+        <p:nvSpPr>
+          <p:cNvPr id="9" name="TextBox 8"/>
+          <p:cNvSpPr txBox="1"/>
+          <p:nvPr/>
+        </p:nvSpPr>
+        <p:spPr>
+          <a:xfrm>
+            <a:off x="457200" y="1920240"/>
+            <a:ext cx="11277295" cy="365760"/>
+          </a:xfrm>
+          <a:prstGeom prst="rect">
+            <a:avLst/>
+          </a:prstGeom>
+          <a:noFill/>
+        </p:spPr>
+        <p:txBody>
+          <a:bodyPr wrap="square" lIns="45720" rIns="45720" tIns="18288" bIns="18288" anchor="t">
+            <a:spAutoFit/>
+          </a:bodyPr>
+          <a:lstStyle/>
+          <a:p>
+            <a:pPr algn="ctr"/>
+            <a:r>
+              <a:rPr sz="1400" b="1">
+                <a:solidFill>
+                  <a:srgbClr val="4F6C2A"/>
+                </a:solidFill>
+                <a:latin typeface="Arial"/>
+              </a:rPr>
+              <a:t>Formel:  Månedlig omsætning  =  N partnere × $50  +  Leads × $50</a:t>
+            </a:r>
+          </a:p>
+        </p:txBody>
+      </p:sp>
+      <p:sp>
+        <p:nvSpPr>
+          <p:cNvPr id="10" name="Rounded Rectangle 9"/>
           <p:cNvSpPr/>
           <p:nvPr/>
         </p:nvSpPr>
         <p:spPr>
           <a:xfrm>
-            <a:off x="746607" y="2560320"/>
+            <a:off x="746607" y="2651760"/>
             <a:ext cx="3383280" cy="3291840"/>
           </a:xfrm>
           <a:prstGeom prst="roundRect">
@@ -8336,13 +8405,13 @@
       </p:sp>
       <p:sp>
         <p:nvSpPr>
-          <p:cNvPr id="10" name="TextBox 9"/>
-          <p:cNvSpPr txBox="1"/>
-          <p:nvPr/>
-        </p:nvSpPr>
-        <p:spPr>
-          <a:xfrm>
-            <a:off x="746607" y="2834640"/>
+          <p:cNvPr id="11" name="TextBox 10"/>
+          <p:cNvSpPr txBox="1"/>
+          <p:nvPr/>
+        </p:nvSpPr>
+        <p:spPr>
+          <a:xfrm>
+            <a:off x="746607" y="2926080"/>
             <a:ext cx="3383280" cy="365760"/>
           </a:xfrm>
           <a:prstGeom prst="rect">
@@ -8364,20 +8433,20 @@
                 </a:solidFill>
                 <a:latin typeface="Arial"/>
               </a:rPr>
-              <a:t>ALL GROWTH</a:t>
-            </a:r>
-          </a:p>
-        </p:txBody>
-      </p:sp>
-      <p:sp>
-        <p:nvSpPr>
-          <p:cNvPr id="11" name="TextBox 10"/>
-          <p:cNvSpPr txBox="1"/>
-          <p:nvPr/>
-        </p:nvSpPr>
-        <p:spPr>
-          <a:xfrm>
-            <a:off x="746607" y="3291840"/>
+              <a:t>A · PARTNER-HEAVY</a:t>
+            </a:r>
+          </a:p>
+        </p:txBody>
+      </p:sp>
+      <p:sp>
+        <p:nvSpPr>
+          <p:cNvPr id="12" name="TextBox 11"/>
+          <p:cNvSpPr txBox="1"/>
+          <p:nvPr/>
+        </p:nvSpPr>
+        <p:spPr>
+          <a:xfrm>
+            <a:off x="746607" y="3383280"/>
             <a:ext cx="3383280" cy="1097280"/>
           </a:xfrm>
           <a:prstGeom prst="rect">
@@ -8399,20 +8468,20 @@
                 </a:solidFill>
                 <a:latin typeface="Georgia"/>
               </a:rPr>
-              <a:t>27</a:t>
-            </a:r>
-          </a:p>
-        </p:txBody>
-      </p:sp>
-      <p:sp>
-        <p:nvSpPr>
-          <p:cNvPr id="12" name="TextBox 11"/>
-          <p:cNvSpPr txBox="1"/>
-          <p:nvPr/>
-        </p:nvSpPr>
-        <p:spPr>
-          <a:xfrm>
-            <a:off x="746607" y="4389120"/>
+              <a:t>50</a:t>
+            </a:r>
+          </a:p>
+        </p:txBody>
+      </p:sp>
+      <p:sp>
+        <p:nvSpPr>
+          <p:cNvPr id="13" name="TextBox 12"/>
+          <p:cNvSpPr txBox="1"/>
+          <p:nvPr/>
+        </p:nvSpPr>
+        <p:spPr>
+          <a:xfrm>
+            <a:off x="746607" y="4480560"/>
             <a:ext cx="3383280" cy="365760"/>
           </a:xfrm>
           <a:prstGeom prst="rect">
@@ -8434,20 +8503,20 @@
                 </a:solidFill>
                 <a:latin typeface="Arial"/>
               </a:rPr>
-              <a:t>betalende partnere</a:t>
-            </a:r>
-          </a:p>
-        </p:txBody>
-      </p:sp>
-      <p:sp>
-        <p:nvSpPr>
-          <p:cNvPr id="13" name="TextBox 12"/>
-          <p:cNvSpPr txBox="1"/>
-          <p:nvPr/>
-        </p:nvSpPr>
-        <p:spPr>
-          <a:xfrm>
-            <a:off x="929487" y="4846320"/>
+              <a:t>partnere + 38 leads/md</a:t>
+            </a:r>
+          </a:p>
+        </p:txBody>
+      </p:sp>
+      <p:sp>
+        <p:nvSpPr>
+          <p:cNvPr id="14" name="TextBox 13"/>
+          <p:cNvSpPr txBox="1"/>
+          <p:nvPr/>
+        </p:nvSpPr>
+        <p:spPr>
+          <a:xfrm>
+            <a:off x="929487" y="4937760"/>
             <a:ext cx="3017520" cy="640080"/>
           </a:xfrm>
           <a:prstGeom prst="rect">
@@ -8469,21 +8538,21 @@
                 </a:solidFill>
                 <a:latin typeface="Arial"/>
               </a:rPr>
-              <a:t>27 × €149
-= €4.023 MRR</a:t>
-            </a:r>
-          </a:p>
-        </p:txBody>
-      </p:sp>
-      <p:sp>
-        <p:nvSpPr>
-          <p:cNvPr id="14" name="TextBox 13"/>
-          <p:cNvSpPr txBox="1"/>
-          <p:nvPr/>
-        </p:nvSpPr>
-        <p:spPr>
-          <a:xfrm>
-            <a:off x="929487" y="5486400"/>
+              <a:t>50 × $50 + 38 × $50
+= $4.400/md</a:t>
+            </a:r>
+          </a:p>
+        </p:txBody>
+      </p:sp>
+      <p:sp>
+        <p:nvSpPr>
+          <p:cNvPr id="15" name="TextBox 14"/>
+          <p:cNvSpPr txBox="1"/>
+          <p:nvPr/>
+        </p:nvSpPr>
+        <p:spPr>
+          <a:xfrm>
+            <a:off x="929487" y="5577840"/>
             <a:ext cx="3017520" cy="365760"/>
           </a:xfrm>
           <a:prstGeom prst="rect">
@@ -8505,20 +8574,20 @@
                 </a:solidFill>
                 <a:latin typeface="Arial"/>
               </a:rPr>
-              <a:t>Lavt billet, høj volumen</a:t>
-            </a:r>
-          </a:p>
-        </p:txBody>
-      </p:sp>
-      <p:sp>
-        <p:nvSpPr>
-          <p:cNvPr id="15" name="Rounded Rectangle 14"/>
+              <a:t>Kræver lift af conversion til 1,5%</a:t>
+            </a:r>
+          </a:p>
+        </p:txBody>
+      </p:sp>
+      <p:sp>
+        <p:nvSpPr>
+          <p:cNvPr id="16" name="Rounded Rectangle 15"/>
           <p:cNvSpPr/>
           <p:nvPr/>
         </p:nvSpPr>
         <p:spPr>
           <a:xfrm>
-            <a:off x="5135727" y="2331720"/>
+            <a:off x="5135727" y="2423160"/>
             <a:ext cx="1920240" cy="365760"/>
           </a:xfrm>
           <a:prstGeom prst="roundRect">
@@ -8555,13 +8624,13 @@
       </p:sp>
       <p:sp>
         <p:nvSpPr>
-          <p:cNvPr id="16" name="TextBox 15"/>
-          <p:cNvSpPr txBox="1"/>
-          <p:nvPr/>
-        </p:nvSpPr>
-        <p:spPr>
-          <a:xfrm>
-            <a:off x="5135727" y="2331720"/>
+          <p:cNvPr id="17" name="TextBox 16"/>
+          <p:cNvSpPr txBox="1"/>
+          <p:nvPr/>
+        </p:nvSpPr>
+        <p:spPr>
+          <a:xfrm>
+            <a:off x="5135727" y="2423160"/>
             <a:ext cx="1920240" cy="365760"/>
           </a:xfrm>
           <a:prstGeom prst="rect">
@@ -8590,13 +8659,13 @@
       </p:sp>
       <p:sp>
         <p:nvSpPr>
-          <p:cNvPr id="17" name="Rounded Rectangle 16"/>
+          <p:cNvPr id="18" name="Rounded Rectangle 17"/>
           <p:cNvSpPr/>
           <p:nvPr/>
         </p:nvSpPr>
         <p:spPr>
           <a:xfrm>
-            <a:off x="4404207" y="2560320"/>
+            <a:off x="4404207" y="2651760"/>
             <a:ext cx="3383280" cy="3291840"/>
           </a:xfrm>
           <a:prstGeom prst="roundRect">
@@ -8633,13 +8702,13 @@
       </p:sp>
       <p:sp>
         <p:nvSpPr>
-          <p:cNvPr id="18" name="Rounded Rectangle 17"/>
+          <p:cNvPr id="19" name="Rounded Rectangle 18"/>
           <p:cNvSpPr/>
           <p:nvPr/>
         </p:nvSpPr>
         <p:spPr>
           <a:xfrm>
-            <a:off x="4468215" y="2624328"/>
+            <a:off x="4468215" y="2715768"/>
             <a:ext cx="3255264" cy="3163824"/>
           </a:xfrm>
           <a:prstGeom prst="roundRect">
@@ -8676,13 +8745,13 @@
       </p:sp>
       <p:sp>
         <p:nvSpPr>
-          <p:cNvPr id="19" name="TextBox 18"/>
-          <p:cNvSpPr txBox="1"/>
-          <p:nvPr/>
-        </p:nvSpPr>
-        <p:spPr>
-          <a:xfrm>
-            <a:off x="4404207" y="2834640"/>
+          <p:cNvPr id="20" name="TextBox 19"/>
+          <p:cNvSpPr txBox="1"/>
+          <p:nvPr/>
+        </p:nvSpPr>
+        <p:spPr>
+          <a:xfrm>
+            <a:off x="4404207" y="2926080"/>
             <a:ext cx="3383280" cy="365760"/>
           </a:xfrm>
           <a:prstGeom prst="rect">
@@ -8704,20 +8773,20 @@
                 </a:solidFill>
                 <a:latin typeface="Arial"/>
               </a:rPr>
-              <a:t>REALISTISK MIX</a:t>
-            </a:r>
-          </a:p>
-        </p:txBody>
-      </p:sp>
-      <p:sp>
-        <p:nvSpPr>
-          <p:cNvPr id="20" name="TextBox 19"/>
-          <p:cNvSpPr txBox="1"/>
-          <p:nvPr/>
-        </p:nvSpPr>
-        <p:spPr>
-          <a:xfrm>
-            <a:off x="4404207" y="3291840"/>
+              <a:t>B · MIX</a:t>
+            </a:r>
+          </a:p>
+        </p:txBody>
+      </p:sp>
+      <p:sp>
+        <p:nvSpPr>
+          <p:cNvPr id="21" name="TextBox 20"/>
+          <p:cNvSpPr txBox="1"/>
+          <p:nvPr/>
+        </p:nvSpPr>
+        <p:spPr>
+          <a:xfrm>
+            <a:off x="4404207" y="3383280"/>
             <a:ext cx="3383280" cy="1097280"/>
           </a:xfrm>
           <a:prstGeom prst="rect">
@@ -8739,20 +8808,20 @@
                 </a:solidFill>
                 <a:latin typeface="Georgia"/>
               </a:rPr>
-              <a:t>15 + 6</a:t>
-            </a:r>
-          </a:p>
-        </p:txBody>
-      </p:sp>
-      <p:sp>
-        <p:nvSpPr>
-          <p:cNvPr id="21" name="TextBox 20"/>
-          <p:cNvSpPr txBox="1"/>
-          <p:nvPr/>
-        </p:nvSpPr>
-        <p:spPr>
-          <a:xfrm>
-            <a:off x="4404207" y="4389120"/>
+              <a:t>40</a:t>
+            </a:r>
+          </a:p>
+        </p:txBody>
+      </p:sp>
+      <p:sp>
+        <p:nvSpPr>
+          <p:cNvPr id="22" name="TextBox 21"/>
+          <p:cNvSpPr txBox="1"/>
+          <p:nvPr/>
+        </p:nvSpPr>
+        <p:spPr>
+          <a:xfrm>
+            <a:off x="4404207" y="4480560"/>
             <a:ext cx="3383280" cy="365760"/>
           </a:xfrm>
           <a:prstGeom prst="rect">
@@ -8774,20 +8843,20 @@
                 </a:solidFill>
                 <a:latin typeface="Arial"/>
               </a:rPr>
-              <a:t>Growth + Enterprise</a:t>
-            </a:r>
-          </a:p>
-        </p:txBody>
-      </p:sp>
-      <p:sp>
-        <p:nvSpPr>
-          <p:cNvPr id="22" name="TextBox 21"/>
-          <p:cNvSpPr txBox="1"/>
-          <p:nvPr/>
-        </p:nvSpPr>
-        <p:spPr>
-          <a:xfrm>
-            <a:off x="4587087" y="4846320"/>
+              <a:t>partnere + 50 leads/md</a:t>
+            </a:r>
+          </a:p>
+        </p:txBody>
+      </p:sp>
+      <p:sp>
+        <p:nvSpPr>
+          <p:cNvPr id="23" name="TextBox 22"/>
+          <p:cNvSpPr txBox="1"/>
+          <p:nvPr/>
+        </p:nvSpPr>
+        <p:spPr>
+          <a:xfrm>
+            <a:off x="4587087" y="4937760"/>
             <a:ext cx="3017520" cy="640080"/>
           </a:xfrm>
           <a:prstGeom prst="rect">
@@ -8809,21 +8878,21 @@
                 </a:solidFill>
                 <a:latin typeface="Arial"/>
               </a:rPr>
-              <a:t>15 × €149 + 6 × €349
-= €4.329 MRR</a:t>
-            </a:r>
-          </a:p>
-        </p:txBody>
-      </p:sp>
-      <p:sp>
-        <p:nvSpPr>
-          <p:cNvPr id="23" name="TextBox 22"/>
-          <p:cNvSpPr txBox="1"/>
-          <p:nvPr/>
-        </p:nvSpPr>
-        <p:spPr>
-          <a:xfrm>
-            <a:off x="4587087" y="5486400"/>
+              <a:t>40 × $50 + 50 × $50
+= $4.500/md ≈ 30.800 DKK</a:t>
+            </a:r>
+          </a:p>
+        </p:txBody>
+      </p:sp>
+      <p:sp>
+        <p:nvSpPr>
+          <p:cNvPr id="24" name="TextBox 23"/>
+          <p:cNvSpPr txBox="1"/>
+          <p:nvPr/>
+        </p:nvSpPr>
+        <p:spPr>
+          <a:xfrm>
+            <a:off x="4587087" y="5577840"/>
             <a:ext cx="3017520" cy="365760"/>
           </a:xfrm>
           <a:prstGeom prst="rect">
@@ -8845,20 +8914,20 @@
                 </a:solidFill>
                 <a:latin typeface="Arial"/>
               </a:rPr>
-              <a:t>≈ 32.250 DKK/md</a:t>
-            </a:r>
-          </a:p>
-        </p:txBody>
-      </p:sp>
-      <p:sp>
-        <p:nvSpPr>
-          <p:cNvPr id="24" name="Rounded Rectangle 23"/>
+              <a:t>Kræver 0,5% quote-conversion @ 10k MAU</a:t>
+            </a:r>
+          </a:p>
+        </p:txBody>
+      </p:sp>
+      <p:sp>
+        <p:nvSpPr>
+          <p:cNvPr id="25" name="Rounded Rectangle 24"/>
           <p:cNvSpPr/>
           <p:nvPr/>
         </p:nvSpPr>
         <p:spPr>
           <a:xfrm>
-            <a:off x="8061807" y="2560320"/>
+            <a:off x="8061807" y="2651760"/>
             <a:ext cx="3383280" cy="3291840"/>
           </a:xfrm>
           <a:prstGeom prst="roundRect">
@@ -8895,13 +8964,13 @@
       </p:sp>
       <p:sp>
         <p:nvSpPr>
-          <p:cNvPr id="25" name="TextBox 24"/>
-          <p:cNvSpPr txBox="1"/>
-          <p:nvPr/>
-        </p:nvSpPr>
-        <p:spPr>
-          <a:xfrm>
-            <a:off x="8061807" y="2834640"/>
+          <p:cNvPr id="26" name="TextBox 25"/>
+          <p:cNvSpPr txBox="1"/>
+          <p:nvPr/>
+        </p:nvSpPr>
+        <p:spPr>
+          <a:xfrm>
+            <a:off x="8061807" y="2926080"/>
             <a:ext cx="3383280" cy="365760"/>
           </a:xfrm>
           <a:prstGeom prst="rect">
@@ -8923,20 +8992,20 @@
                 </a:solidFill>
                 <a:latin typeface="Arial"/>
               </a:rPr>
-              <a:t>ALL ENTERPRISE</a:t>
-            </a:r>
-          </a:p>
-        </p:txBody>
-      </p:sp>
-      <p:sp>
-        <p:nvSpPr>
-          <p:cNvPr id="26" name="TextBox 25"/>
-          <p:cNvSpPr txBox="1"/>
-          <p:nvPr/>
-        </p:nvSpPr>
-        <p:spPr>
-          <a:xfrm>
-            <a:off x="8061807" y="3291840"/>
+              <a:t>C · LEAD-HEAVY</a:t>
+            </a:r>
+          </a:p>
+        </p:txBody>
+      </p:sp>
+      <p:sp>
+        <p:nvSpPr>
+          <p:cNvPr id="27" name="TextBox 26"/>
+          <p:cNvSpPr txBox="1"/>
+          <p:nvPr/>
+        </p:nvSpPr>
+        <p:spPr>
+          <a:xfrm>
+            <a:off x="8061807" y="3383280"/>
             <a:ext cx="3383280" cy="1097280"/>
           </a:xfrm>
           <a:prstGeom prst="rect">
@@ -8958,20 +9027,20 @@
                 </a:solidFill>
                 <a:latin typeface="Georgia"/>
               </a:rPr>
-              <a:t>12</a:t>
-            </a:r>
-          </a:p>
-        </p:txBody>
-      </p:sp>
-      <p:sp>
-        <p:nvSpPr>
-          <p:cNvPr id="27" name="TextBox 26"/>
-          <p:cNvSpPr txBox="1"/>
-          <p:nvPr/>
-        </p:nvSpPr>
-        <p:spPr>
-          <a:xfrm>
-            <a:off x="8061807" y="4389120"/>
+              <a:t>20</a:t>
+            </a:r>
+          </a:p>
+        </p:txBody>
+      </p:sp>
+      <p:sp>
+        <p:nvSpPr>
+          <p:cNvPr id="28" name="TextBox 27"/>
+          <p:cNvSpPr txBox="1"/>
+          <p:nvPr/>
+        </p:nvSpPr>
+        <p:spPr>
+          <a:xfrm>
+            <a:off x="8061807" y="4480560"/>
             <a:ext cx="3383280" cy="365760"/>
           </a:xfrm>
           <a:prstGeom prst="rect">
@@ -8993,20 +9062,20 @@
                 </a:solidFill>
                 <a:latin typeface="Arial"/>
               </a:rPr>
-              <a:t>betalende partnere</a:t>
-            </a:r>
-          </a:p>
-        </p:txBody>
-      </p:sp>
-      <p:sp>
-        <p:nvSpPr>
-          <p:cNvPr id="28" name="TextBox 27"/>
-          <p:cNvSpPr txBox="1"/>
-          <p:nvPr/>
-        </p:nvSpPr>
-        <p:spPr>
-          <a:xfrm>
-            <a:off x="8244687" y="4846320"/>
+              <a:t>partnere + 70 leads/md</a:t>
+            </a:r>
+          </a:p>
+        </p:txBody>
+      </p:sp>
+      <p:sp>
+        <p:nvSpPr>
+          <p:cNvPr id="29" name="TextBox 28"/>
+          <p:cNvSpPr txBox="1"/>
+          <p:nvPr/>
+        </p:nvSpPr>
+        <p:spPr>
+          <a:xfrm>
+            <a:off x="8244687" y="4937760"/>
             <a:ext cx="3017520" cy="640080"/>
           </a:xfrm>
           <a:prstGeom prst="rect">
@@ -9028,21 +9097,21 @@
                 </a:solidFill>
                 <a:latin typeface="Arial"/>
               </a:rPr>
-              <a:t>12 × €349
-= €4.188 MRR</a:t>
-            </a:r>
-          </a:p>
-        </p:txBody>
-      </p:sp>
-      <p:sp>
-        <p:nvSpPr>
-          <p:cNvPr id="29" name="TextBox 28"/>
-          <p:cNvSpPr txBox="1"/>
-          <p:nvPr/>
-        </p:nvSpPr>
-        <p:spPr>
-          <a:xfrm>
-            <a:off x="8244687" y="5486400"/>
+              <a:t>20 × $50 + 70 × $50
+= $4.500/md</a:t>
+            </a:r>
+          </a:p>
+        </p:txBody>
+      </p:sp>
+      <p:sp>
+        <p:nvSpPr>
+          <p:cNvPr id="30" name="TextBox 29"/>
+          <p:cNvSpPr txBox="1"/>
+          <p:nvPr/>
+        </p:nvSpPr>
+        <p:spPr>
+          <a:xfrm>
+            <a:off x="8244687" y="5577840"/>
             <a:ext cx="3017520" cy="365760"/>
           </a:xfrm>
           <a:prstGeom prst="rect">
@@ -9064,14 +9133,14 @@
                 </a:solidFill>
                 <a:latin typeface="Arial"/>
               </a:rPr>
-              <a:t>Højere billet, færre kunder</a:t>
-            </a:r>
-          </a:p>
-        </p:txBody>
-      </p:sp>
-      <p:sp>
-        <p:nvSpPr>
-          <p:cNvPr id="30" name="TextBox 29"/>
+              <a:t>Få men aktive partnere, churn-risk</a:t>
+            </a:r>
+          </a:p>
+        </p:txBody>
+      </p:sp>
+      <p:sp>
+        <p:nvSpPr>
+          <p:cNvPr id="31" name="TextBox 30"/>
           <p:cNvSpPr txBox="1"/>
           <p:nvPr/>
         </p:nvSpPr>
@@ -9099,7 +9168,7 @@
                 </a:solidFill>
                 <a:latin typeface="Arial"/>
               </a:rPr>
-              <a:t>I dag: 1 betalende partner (AM Printservice). Gap til mål: 14-26 partnere afhængigt af mix.</a:t>
+              <a:t>I dag: 1 partner × $600 banked + 0 leads. Gap til 30k DKK/md: 19-49 partnere + lead-conversion-lift.</a:t>
             </a:r>
           </a:p>
         </p:txBody>
@@ -9849,7 +9918,7 @@
                 </a:solidFill>
                 <a:latin typeface="Arial"/>
               </a:rPr>
-              <a:t>Outbound click / quote sendt</a:t>
+              <a:t>Quote-form-submit  →  $50</a:t>
             </a:r>
           </a:p>
           <a:p>
@@ -9861,7 +9930,7 @@
                 </a:solidFill>
                 <a:latin typeface="Arial"/>
               </a:rPr>
-              <a:t>   ·   outbound_click = konvertering</a:t>
+              <a:t>   ·   quote_request_submit = revenue</a:t>
             </a:r>
           </a:p>
         </p:txBody>
@@ -10178,7 +10247,7 @@
                 </a:solidFill>
                 <a:latin typeface="Arial"/>
               </a:rPr>
-              <a:t>   ·   outbound + quote (gap)</a:t>
+              <a:t>   ·   quote_submit + supplier_id (gap)</a:t>
             </a:r>
           </a:p>
         </p:txBody>
@@ -10370,7 +10439,7 @@
                 </a:solidFill>
                 <a:latin typeface="Arial"/>
               </a:rPr>
-              <a:t>Tier-upgrade til betalende</a:t>
+              <a:t>Underskriv $600/år-kontrakt</a:t>
             </a:r>
           </a:p>
           <a:p>
@@ -10382,7 +10451,7 @@
                 </a:solidFill>
                 <a:latin typeface="Arial"/>
               </a:rPr>
-              <a:t>   ·   is_partner=true · MRR</a:t>
+              <a:t>   ·   is_partner=true · cash up front</a:t>
             </a:r>
           </a:p>
         </p:txBody>
@@ -12113,7 +12182,7 @@
                 </a:solidFill>
                 <a:latin typeface="Arial"/>
               </a:rPr>
-              <a:t>Outbound clicks (konvertering)</a:t>
+              <a:t>Outbound clicks</a:t>
             </a:r>
           </a:p>
         </p:txBody>
@@ -12384,9 +12453,9 @@
           <a:p>
             <a:pPr algn="ctr"/>
             <a:r>
-              <a:rPr sz="1300" b="0">
-                <a:solidFill>
-                  <a:srgbClr val="333333"/>
+              <a:rPr sz="1400" b="1">
+                <a:solidFill>
+                  <a:srgbClr val="4F6C2A"/>
                 </a:solidFill>
                 <a:latin typeface="Arial"/>
               </a:rPr>
@@ -12419,13 +12488,13 @@
           <a:p>
             <a:pPr algn="l"/>
             <a:r>
-              <a:rPr sz="1300" b="0">
-                <a:solidFill>
-                  <a:srgbClr val="333333"/>
+              <a:rPr sz="1400" b="1">
+                <a:solidFill>
+                  <a:srgbClr val="4F6C2A"/>
                 </a:solidFill>
                 <a:latin typeface="Arial"/>
               </a:rPr>
-              <a:t>Quote requests</a:t>
+              <a:t>Quote-form-submits  ⇒  $50/stk</a:t>
             </a:r>
           </a:p>
         </p:txBody>
@@ -12454,9 +12523,9 @@
           <a:p>
             <a:pPr algn="l"/>
             <a:r>
-              <a:rPr sz="1300" b="0">
-                <a:solidFill>
-                  <a:srgbClr val="333333"/>
+              <a:rPr sz="1400" b="1">
+                <a:solidFill>
+                  <a:srgbClr val="4F6C2A"/>
                 </a:solidFill>
                 <a:latin typeface="Arial"/>
               </a:rPr>
@@ -12489,13 +12558,13 @@
           <a:p>
             <a:pPr algn="l"/>
             <a:r>
-              <a:rPr sz="1300" b="1">
+              <a:rPr sz="1400" b="1">
                 <a:solidFill>
                   <a:srgbClr val="4F6C2A"/>
                 </a:solidFill>
                 <a:latin typeface="Arial"/>
               </a:rPr>
-              <a:t>~25</a:t>
+              <a:t>~12  ($600/uge)</a:t>
             </a:r>
           </a:p>
         </p:txBody>
@@ -12737,7 +12806,7 @@
                 </a:solidFill>
                 <a:latin typeface="Arial"/>
               </a:rPr>
-              <a:t>Conv-rate visit → outbound</a:t>
+              <a:t>Quote-form conversion-rate</a:t>
             </a:r>
           </a:p>
         </p:txBody>
@@ -12772,7 +12841,7 @@
                 </a:solidFill>
                 <a:latin typeface="Arial"/>
               </a:rPr>
-              <a:t>beregnet</a:t>
+              <a:t>beregnet (submits/visits)</a:t>
             </a:r>
           </a:p>
         </p:txBody>
@@ -12807,7 +12876,7 @@
                 </a:solidFill>
                 <a:latin typeface="Arial"/>
               </a:rPr>
-              <a:t>3,0%</a:t>
+              <a:t>0,5%  (i dag ~0,25%)</a:t>
             </a:r>
           </a:p>
         </p:txBody>
@@ -12836,13 +12905,13 @@
           <a:p>
             <a:pPr algn="l"/>
             <a:r>
-              <a:rPr sz="1200" b="0">
-                <a:solidFill>
-                  <a:srgbClr val="555555"/>
+              <a:rPr sz="1200" b="1">
+                <a:solidFill>
+                  <a:srgbClr val="4F6C2A"/>
                 </a:solidFill>
                 <a:latin typeface="Arial"/>
               </a:rPr>
-              <a:t>Konverteringen er outbound_click → supplier-website. Quote-form-submit er stærkere signal men sjældnere.</a:t>
+              <a:t>KPI #5 = revenue-event ($50 pr. submit). KPI #6 = højeste leverage: lift 0,25% → 0,5% = 2× lead-revenue uden ny trafik.</a:t>
             </a:r>
           </a:p>
         </p:txBody>
@@ -13949,7 +14018,7 @@
                 </a:solidFill>
                 <a:latin typeface="Arial"/>
               </a:rPr>
-              <a:t>Leads leveret pr. partner (mdr.)</a:t>
+              <a:t>Leads leveret pr. partner (uge)</a:t>
             </a:r>
           </a:p>
         </p:txBody>
@@ -13984,7 +14053,7 @@
                 </a:solidFill>
                 <a:latin typeface="Arial"/>
               </a:rPr>
-              <a:t>outbound + quote</a:t>
+              <a:t>quote_submit + supplier_id</a:t>
             </a:r>
           </a:p>
         </p:txBody>
@@ -14261,7 +14330,7 @@
                 </a:solidFill>
                 <a:latin typeface="Arial"/>
               </a:rPr>
-              <a:t>Booked partner-samtaler</a:t>
+              <a:t>Booked partner-samtaler (uge)</a:t>
             </a:r>
           </a:p>
         </p:txBody>
@@ -14573,7 +14642,7 @@
                 </a:solidFill>
                 <a:latin typeface="Arial"/>
               </a:rPr>
-              <a:t>Nye betalende partnere/uge</a:t>
+              <a:t>Nye partnere (uge) × $600</a:t>
             </a:r>
           </a:p>
         </p:txBody>
@@ -14885,7 +14954,7 @@
                 </a:solidFill>
                 <a:latin typeface="Arial"/>
               </a:rPr>
-              <a:t>MRR (DKK)</a:t>
+              <a:t>Annual revenue booked (kvt.)</a:t>
             </a:r>
           </a:p>
         </p:txBody>
@@ -14920,7 +14989,7 @@
                 </a:solidFill>
                 <a:latin typeface="Arial"/>
               </a:rPr>
-              <a:t>mangler tabel</a:t>
+              <a:t>$600 × nye partnere</a:t>
             </a:r>
           </a:p>
         </p:txBody>
@@ -15197,7 +15266,7 @@
                 </a:solidFill>
                 <a:latin typeface="Arial"/>
               </a:rPr>
-              <a:t>Churn (kr. tabt sidste 30 dage)</a:t>
+              <a:t>Renewal-rate (efter 12 mdr.)</a:t>
             </a:r>
           </a:p>
         </p:txBody>
@@ -15232,7 +15301,7 @@
                 </a:solidFill>
                 <a:latin typeface="Arial"/>
               </a:rPr>
-              <a:t>mangler</a:t>
+              <a:t>fra md. 13</a:t>
             </a:r>
           </a:p>
         </p:txBody>
@@ -15263,11 +15332,11 @@
             <a:r>
               <a:rPr sz="1300" b="1">
                 <a:solidFill>
-                  <a:srgbClr val="CC4444"/>
+                  <a:srgbClr val="E0A030"/>
                 </a:solidFill>
                 <a:latin typeface="Arial"/>
               </a:rPr>
-              <a:t>GAP</a:t>
+              <a:t>FREMTID</a:t>
             </a:r>
           </a:p>
         </p:txBody>
@@ -15302,7 +15371,7 @@
                 </a:solidFill>
                 <a:latin typeface="Arial"/>
               </a:rPr>
-              <a:t>4 ud af 6 KPI'er har gaps. Instrumentation skal bygges — se slide 10.</a:t>
+              <a:t>3 GAPs + 1 fremtid. Lead-attribution (KPI #8) er revenue-kritisk — hver utracket submit = $50 tabt. Se slide 10.</a:t>
             </a:r>
           </a:p>
         </p:txBody>
@@ -15890,7 +15959,7 @@
                 </a:solidFill>
                 <a:latin typeface="Arial"/>
               </a:rPr>
-              <a:t>STL-uploads/uge</a:t>
+              <a:t>Quote-form-submits/uge</a:t>
             </a:r>
           </a:p>
         </p:txBody>
@@ -15960,7 +16029,7 @@
                 </a:solidFill>
                 <a:latin typeface="Arial"/>
               </a:rPr>
-              <a:t>mål: 125</a:t>
+              <a:t>mål: 12 ($600/uge)</a:t>
             </a:r>
           </a:p>
         </p:txBody>
@@ -16081,7 +16150,7 @@
                 </a:solidFill>
                 <a:latin typeface="Arial"/>
               </a:rPr>
-              <a:t>Supplier-views/uge</a:t>
+              <a:t>Conversion-rate</a:t>
             </a:r>
           </a:p>
         </p:txBody>
@@ -16151,7 +16220,7 @@
                 </a:solidFill>
                 <a:latin typeface="Arial"/>
               </a:rPr>
-              <a:t>mål: 500</a:t>
+              <a:t>mål: 0,5%</a:t>
             </a:r>
           </a:p>
         </p:txBody>
@@ -16845,7 +16914,7 @@
                 </a:solidFill>
                 <a:latin typeface="Arial"/>
               </a:rPr>
-              <a:t>MRR (DKK)</a:t>
+              <a:t>Revenue booked YTD</a:t>
             </a:r>
           </a:p>
         </p:txBody>
@@ -16880,7 +16949,7 @@
                 </a:solidFill>
                 <a:latin typeface="Georgia"/>
               </a:rPr>
-              <a:t>~3.500</a:t>
+              <a:t>$600</a:t>
             </a:r>
           </a:p>
         </p:txBody>
@@ -16915,7 +16984,7 @@
                 </a:solidFill>
                 <a:latin typeface="Arial"/>
               </a:rPr>
-              <a:t>Growth-tier</a:t>
+              <a:t>1 × $600/år</a:t>
             </a:r>
           </a:p>
         </p:txBody>
@@ -17036,7 +17105,7 @@
                 </a:solidFill>
                 <a:latin typeface="Arial"/>
               </a:rPr>
-              <a:t>Gap til 30k/md</a:t>
+              <a:t>Gap til 30k DKK/md</a:t>
             </a:r>
           </a:p>
         </p:txBody>
@@ -17071,7 +17140,7 @@
                 </a:solidFill>
                 <a:latin typeface="Georgia"/>
               </a:rPr>
-              <a:t>26.500</a:t>
+              <a:t>$4.350</a:t>
             </a:r>
           </a:p>
         </p:txBody>
@@ -17106,7 +17175,7 @@
                 </a:solidFill>
                 <a:latin typeface="Arial"/>
               </a:rPr>
-              <a:t>DKK at indhente</a:t>
+              <a:t>≈ 29.800 DKK</a:t>
             </a:r>
           </a:p>
         </p:txBody>
@@ -18224,11 +18293,11 @@
             <a:r>
               <a:rPr sz="1200" b="1">
                 <a:solidFill>
-                  <a:srgbClr val="333333"/>
+                  <a:srgbClr val="4F6C2A"/>
                 </a:solidFill>
                 <a:latin typeface="Arial"/>
               </a:rPr>
-              <a:t>Headline-metric: 3% af besøgende klikker ud til en supplier-side. Forbedring her er højeste leverage.</a:t>
+              <a:t>Headline-revenue: hver Quote-form-submit = $50. Lift 0,25% → 0,5% = $1.250/md ekstra uden ny trafik.</a:t>
             </a:r>
           </a:p>
         </p:txBody>

</xml_diff>